<commit_message>
new slides and enriched route
</commit_message>
<xml_diff>
--- a/技术方案与工作排期/技术路线.pptx
+++ b/技术方案与工作排期/技术路线.pptx
@@ -261,7 +261,7 @@
           <a:p>
             <a:fld id="{D799EC43-B335-4C85-9787-5DCC3E5F613C}" type="datetimeFigureOut">
               <a:rPr lang="zh-CN" altLang="en-US" smtClean="0"/>
-              <a:t>2026-03-07</a:t>
+              <a:t>2026-03-09</a:t>
             </a:fld>
             <a:endParaRPr lang="zh-CN" altLang="en-US"/>
           </a:p>
@@ -459,7 +459,7 @@
           <a:p>
             <a:fld id="{D799EC43-B335-4C85-9787-5DCC3E5F613C}" type="datetimeFigureOut">
               <a:rPr lang="zh-CN" altLang="en-US" smtClean="0"/>
-              <a:t>2026-03-07</a:t>
+              <a:t>2026-03-09</a:t>
             </a:fld>
             <a:endParaRPr lang="zh-CN" altLang="en-US"/>
           </a:p>
@@ -667,7 +667,7 @@
           <a:p>
             <a:fld id="{D799EC43-B335-4C85-9787-5DCC3E5F613C}" type="datetimeFigureOut">
               <a:rPr lang="zh-CN" altLang="en-US" smtClean="0"/>
-              <a:t>2026-03-07</a:t>
+              <a:t>2026-03-09</a:t>
             </a:fld>
             <a:endParaRPr lang="zh-CN" altLang="en-US"/>
           </a:p>
@@ -865,7 +865,7 @@
           <a:p>
             <a:fld id="{D799EC43-B335-4C85-9787-5DCC3E5F613C}" type="datetimeFigureOut">
               <a:rPr lang="zh-CN" altLang="en-US" smtClean="0"/>
-              <a:t>2026-03-07</a:t>
+              <a:t>2026-03-09</a:t>
             </a:fld>
             <a:endParaRPr lang="zh-CN" altLang="en-US"/>
           </a:p>
@@ -1140,7 +1140,7 @@
           <a:p>
             <a:fld id="{D799EC43-B335-4C85-9787-5DCC3E5F613C}" type="datetimeFigureOut">
               <a:rPr lang="zh-CN" altLang="en-US" smtClean="0"/>
-              <a:t>2026-03-07</a:t>
+              <a:t>2026-03-09</a:t>
             </a:fld>
             <a:endParaRPr lang="zh-CN" altLang="en-US"/>
           </a:p>
@@ -1405,7 +1405,7 @@
           <a:p>
             <a:fld id="{D799EC43-B335-4C85-9787-5DCC3E5F613C}" type="datetimeFigureOut">
               <a:rPr lang="zh-CN" altLang="en-US" smtClean="0"/>
-              <a:t>2026-03-07</a:t>
+              <a:t>2026-03-09</a:t>
             </a:fld>
             <a:endParaRPr lang="zh-CN" altLang="en-US"/>
           </a:p>
@@ -1817,7 +1817,7 @@
           <a:p>
             <a:fld id="{D799EC43-B335-4C85-9787-5DCC3E5F613C}" type="datetimeFigureOut">
               <a:rPr lang="zh-CN" altLang="en-US" smtClean="0"/>
-              <a:t>2026-03-07</a:t>
+              <a:t>2026-03-09</a:t>
             </a:fld>
             <a:endParaRPr lang="zh-CN" altLang="en-US"/>
           </a:p>
@@ -1958,7 +1958,7 @@
           <a:p>
             <a:fld id="{D799EC43-B335-4C85-9787-5DCC3E5F613C}" type="datetimeFigureOut">
               <a:rPr lang="zh-CN" altLang="en-US" smtClean="0"/>
-              <a:t>2026-03-07</a:t>
+              <a:t>2026-03-09</a:t>
             </a:fld>
             <a:endParaRPr lang="zh-CN" altLang="en-US"/>
           </a:p>
@@ -2071,7 +2071,7 @@
           <a:p>
             <a:fld id="{D799EC43-B335-4C85-9787-5DCC3E5F613C}" type="datetimeFigureOut">
               <a:rPr lang="zh-CN" altLang="en-US" smtClean="0"/>
-              <a:t>2026-03-07</a:t>
+              <a:t>2026-03-09</a:t>
             </a:fld>
             <a:endParaRPr lang="zh-CN" altLang="en-US"/>
           </a:p>
@@ -2382,7 +2382,7 @@
           <a:p>
             <a:fld id="{D799EC43-B335-4C85-9787-5DCC3E5F613C}" type="datetimeFigureOut">
               <a:rPr lang="zh-CN" altLang="en-US" smtClean="0"/>
-              <a:t>2026-03-07</a:t>
+              <a:t>2026-03-09</a:t>
             </a:fld>
             <a:endParaRPr lang="zh-CN" altLang="en-US"/>
           </a:p>
@@ -2670,7 +2670,7 @@
           <a:p>
             <a:fld id="{D799EC43-B335-4C85-9787-5DCC3E5F613C}" type="datetimeFigureOut">
               <a:rPr lang="zh-CN" altLang="en-US" smtClean="0"/>
-              <a:t>2026-03-07</a:t>
+              <a:t>2026-03-09</a:t>
             </a:fld>
             <a:endParaRPr lang="zh-CN" altLang="en-US"/>
           </a:p>
@@ -2911,7 +2911,7 @@
           <a:p>
             <a:fld id="{D799EC43-B335-4C85-9787-5DCC3E5F613C}" type="datetimeFigureOut">
               <a:rPr lang="zh-CN" altLang="en-US" smtClean="0"/>
-              <a:t>2026-03-07</a:t>
+              <a:t>2026-03-09</a:t>
             </a:fld>
             <a:endParaRPr lang="zh-CN" altLang="en-US"/>
           </a:p>
@@ -3863,7 +3863,7 @@
         <p:spPr>
           <a:xfrm>
             <a:off x="599387" y="1860628"/>
-            <a:ext cx="4836909" cy="738664"/>
+            <a:ext cx="4836909" cy="307777"/>
           </a:xfrm>
           <a:prstGeom prst="rect">
             <a:avLst/>
@@ -3893,12 +3893,6 @@
               <a:t>进行调研</a:t>
             </a:r>
             <a:endParaRPr lang="en-US" altLang="zh-CN" sz="1400" dirty="0"/>
-          </a:p>
-          <a:p>
-            <a:r>
-              <a:rPr lang="zh-CN" altLang="en-US" sz="1400" dirty="0"/>
-              <a:t>因为不同疾病，可能会有不同的影像协议（需要确认）、报告模板、治疗路径、随访终点都会散掉。</a:t>
-            </a:r>
           </a:p>
         </p:txBody>
       </p:sp>
@@ -4410,8 +4404,8 @@
         </p:nvSpPr>
         <p:spPr>
           <a:xfrm>
-            <a:off x="4496843" y="4711837"/>
-            <a:ext cx="7041829" cy="830997"/>
+            <a:off x="599385" y="6001137"/>
+            <a:ext cx="7041829" cy="646331"/>
           </a:xfrm>
           <a:prstGeom prst="rect">
             <a:avLst/>
@@ -4426,7 +4420,7 @@
           <a:p>
             <a:r>
               <a:rPr lang="zh-CN" altLang="en-US" sz="1200" dirty="0"/>
-              <a:t>如果暂时没有足够院内成对数据，脑肿瘤方向至少有公开的 </a:t>
+              <a:t>如果暂时没有足够院内成对数据，脑肿瘤方向有公开的 </a:t>
             </a:r>
             <a:r>
               <a:rPr lang="en-US" altLang="zh-CN" sz="1200" dirty="0" err="1"/>
@@ -4494,31 +4488,7 @@
             </a:r>
             <a:r>
               <a:rPr lang="zh-CN" altLang="en-US" sz="1200" dirty="0"/>
-              <a:t>与文本描述配对，</a:t>
-            </a:r>
-            <a:r>
-              <a:rPr lang="en-US" altLang="zh-CN" sz="1200" dirty="0"/>
-              <a:t>NOVA </a:t>
-            </a:r>
-            <a:r>
-              <a:rPr lang="zh-CN" altLang="en-US" sz="1200" dirty="0"/>
-              <a:t>则强调脑 </a:t>
-            </a:r>
-            <a:r>
-              <a:rPr lang="en-US" altLang="zh-CN" sz="1200" dirty="0"/>
-              <a:t>MRI </a:t>
-            </a:r>
-            <a:r>
-              <a:rPr lang="zh-CN" altLang="en-US" sz="1200" dirty="0"/>
-              <a:t>中异常定位与临床推理 </a:t>
-            </a:r>
-            <a:r>
-              <a:rPr lang="en-US" altLang="zh-CN" sz="1200" dirty="0"/>
-              <a:t>benchmark</a:t>
-            </a:r>
-            <a:r>
-              <a:rPr lang="zh-CN" altLang="en-US" sz="1200" dirty="0"/>
-              <a:t>，这比泛泛做“神经外科全病种大模型”更落地。 </a:t>
+              <a:t>与文本描述配对</a:t>
             </a:r>
           </a:p>
         </p:txBody>

</xml_diff>